<commit_message>
Update: dashboard UI fixes, server changes, alert sound, PPT, static assets, and test files
</commit_message>
<xml_diff>
--- a/Cyber_Pirates_GenXHack_Presentation.pptx
+++ b/Cyber_Pirates_GenXHack_Presentation.pptx
@@ -564,7 +564,7 @@
             </a:ln>
             <a:extLst>
               <a:ext uri="{91240B29-F687-4f45-9708-019B960494DF}">
-                <a14:hiddenLine xmlns:a14="http://schemas.microsoft.com/office/drawing/2010/main" xmlns="" w="9525">
+                <a14:hiddenLine xmlns="" xmlns:a14="http://schemas.microsoft.com/office/drawing/2010/main" w="9525">
                   <a:solidFill>
                     <a:srgbClr val="000000"/>
                   </a:solidFill>
@@ -1645,7 +1645,7 @@
             </a:ln>
             <a:extLst>
               <a:ext uri="{91240B29-F687-4f45-9708-019B960494DF}">
-                <a14:hiddenLine xmlns:a14="http://schemas.microsoft.com/office/drawing/2010/main" xmlns="" w="9525">
+                <a14:hiddenLine xmlns="" xmlns:a14="http://schemas.microsoft.com/office/drawing/2010/main" w="9525">
                   <a:solidFill>
                     <a:srgbClr val="000000"/>
                   </a:solidFill>
@@ -2731,7 +2731,7 @@
             </a:ln>
             <a:extLst>
               <a:ext uri="{91240B29-F687-4f45-9708-019B960494DF}">
-                <a14:hiddenLine xmlns:a14="http://schemas.microsoft.com/office/drawing/2010/main" xmlns="" w="9525">
+                <a14:hiddenLine xmlns="" xmlns:a14="http://schemas.microsoft.com/office/drawing/2010/main" w="9525">
                   <a:solidFill>
                     <a:srgbClr val="000000"/>
                   </a:solidFill>
@@ -3692,7 +3692,7 @@
             </a:ln>
             <a:extLst>
               <a:ext uri="{91240B29-F687-4f45-9708-019B960494DF}">
-                <a14:hiddenLine xmlns:a14="http://schemas.microsoft.com/office/drawing/2010/main" xmlns="" w="9525">
+                <a14:hiddenLine xmlns="" xmlns:a14="http://schemas.microsoft.com/office/drawing/2010/main" w="9525">
                   <a:solidFill>
                     <a:srgbClr val="000000"/>
                   </a:solidFill>
@@ -4807,7 +4807,7 @@
             </a:ln>
             <a:extLst>
               <a:ext uri="{91240B29-F687-4f45-9708-019B960494DF}">
-                <a14:hiddenLine xmlns:a14="http://schemas.microsoft.com/office/drawing/2010/main" xmlns="" w="9525">
+                <a14:hiddenLine xmlns="" xmlns:a14="http://schemas.microsoft.com/office/drawing/2010/main" w="9525">
                   <a:solidFill>
                     <a:srgbClr val="000000"/>
                   </a:solidFill>
@@ -7556,7 +7556,7 @@
           </a:ln>
           <a:extLst>
             <a:ext uri="{91240B29-F687-4f45-9708-019B960494DF}">
-              <a14:hiddenLine xmlns:a14="http://schemas.microsoft.com/office/drawing/2010/main" xmlns="" w="9525">
+              <a14:hiddenLine xmlns="" xmlns:a14="http://schemas.microsoft.com/office/drawing/2010/main" w="9525">
                 <a:solidFill>
                   <a:srgbClr val="000000"/>
                 </a:solidFill>
@@ -8731,7 +8731,7 @@
             </a:ln>
             <a:extLst>
               <a:ext uri="{91240B29-F687-4f45-9708-019B960494DF}">
-                <a14:hiddenLine xmlns:a14="http://schemas.microsoft.com/office/drawing/2010/main" xmlns="" w="9525">
+                <a14:hiddenLine xmlns="" xmlns:a14="http://schemas.microsoft.com/office/drawing/2010/main" w="9525">
                   <a:solidFill>
                     <a:srgbClr val="000000"/>
                   </a:solidFill>
@@ -10699,7 +10699,7 @@
             </a:ln>
             <a:extLst>
               <a:ext uri="{91240B29-F687-4f45-9708-019B960494DF}">
-                <a14:hiddenLine xmlns:a14="http://schemas.microsoft.com/office/drawing/2010/main" xmlns="" w="9525">
+                <a14:hiddenLine xmlns="" xmlns:a14="http://schemas.microsoft.com/office/drawing/2010/main" w="9525">
                   <a:solidFill>
                     <a:srgbClr val="000000"/>
                   </a:solidFill>
@@ -11757,7 +11757,7 @@
             </a:ln>
             <a:extLst>
               <a:ext uri="{91240B29-F687-4f45-9708-019B960494DF}">
-                <a14:hiddenLine xmlns:a14="http://schemas.microsoft.com/office/drawing/2010/main" xmlns="" w="9525">
+                <a14:hiddenLine xmlns="" xmlns:a14="http://schemas.microsoft.com/office/drawing/2010/main" w="9525">
                   <a:solidFill>
                     <a:srgbClr val="000000"/>
                   </a:solidFill>
@@ -12807,7 +12807,7 @@
             </a:ln>
             <a:extLst>
               <a:ext uri="{91240B29-F687-4f45-9708-019B960494DF}">
-                <a14:hiddenLine xmlns:a14="http://schemas.microsoft.com/office/drawing/2010/main" xmlns="" w="9525">
+                <a14:hiddenLine xmlns="" xmlns:a14="http://schemas.microsoft.com/office/drawing/2010/main" w="9525">
                   <a:solidFill>
                     <a:srgbClr val="000000"/>
                   </a:solidFill>
@@ -13517,12 +13517,18 @@
             <p:ph type="title"/>
           </p:nvPr>
         </p:nvSpPr>
-        <p:spPr/>
+        <p:spPr>
+          <a:xfrm>
+            <a:off x="1643210" y="1375154"/>
+            <a:ext cx="6343672" cy="709865"/>
+          </a:xfrm>
+        </p:spPr>
         <p:txBody>
           <a:bodyPr/>
           <a:lstStyle/>
           <a:p>
             <a:r>
+              <a:rPr dirty="0"/>
               <a:t>GENXHACK -26 HACKATHON</a:t>
             </a:r>
           </a:p>
@@ -13538,50 +13544,110 @@
             <p:ph idx="1"/>
           </p:nvPr>
         </p:nvSpPr>
-        <p:spPr/>
+        <p:spPr>
+          <a:xfrm>
+            <a:off x="864382" y="2489200"/>
+            <a:ext cx="7356074" cy="3530600"/>
+          </a:xfrm>
+        </p:spPr>
         <p:txBody>
           <a:bodyPr>
-            <a:normAutofit lnSpcReduction="10000"/>
+            <a:normAutofit/>
           </a:bodyPr>
           <a:lstStyle/>
           <a:p>
             <a:r>
-              <a:t>Problem Statement Theme: Cybersecurity / AI Security</a:t>
-            </a:r>
-          </a:p>
-          <a:p>
-            <a:r>
-              <a:t>Problem Statement Title: AI-Powered Behavioral File Integrity Monitoring</a:t>
-            </a:r>
-          </a:p>
-          <a:p>
-            <a:endParaRPr/>
-          </a:p>
-          <a:p>
-            <a:r>
+              <a:rPr sz="2000" b="1" dirty="0"/>
+              <a:t>Problem Statement Theme:</a:t>
+            </a:r>
+            <a:r>
+              <a:rPr lang="en-US" sz="2000" b="1" dirty="0"/>
+              <a:t> Next – Gen Cyber Defense</a:t>
+            </a:r>
+            <a:endParaRPr sz="2000" b="1" dirty="0"/>
+          </a:p>
+          <a:p>
+            <a:r>
+              <a:rPr sz="2000" b="1" dirty="0"/>
+              <a:t>Problem Statement Title:</a:t>
+            </a:r>
+            <a:r>
+              <a:rPr lang="en-US" sz="2000" b="1" dirty="0"/>
+              <a:t> Corporate Insider Threat Monitoring system</a:t>
+            </a:r>
+            <a:endParaRPr sz="2000" dirty="0"/>
+          </a:p>
+          <a:p>
+            <a:r>
+              <a:rPr sz="2000" b="1" dirty="0"/>
               <a:t>Team Name: Cyber Pirates</a:t>
             </a:r>
-          </a:p>
-          <a:p>
-            <a:endParaRPr/>
-          </a:p>
-          <a:p>
-            <a:r>
+            <a:endParaRPr sz="2000" dirty="0"/>
+          </a:p>
+          <a:p>
+            <a:r>
+              <a:rPr sz="2000" b="1" dirty="0"/>
               <a:t>Team Members:</a:t>
             </a:r>
           </a:p>
           <a:p>
-            <a:r>
+            <a:pPr marL="0" indent="0">
+              <a:buNone/>
+            </a:pPr>
+            <a:r>
+              <a:rPr lang="en-US" sz="2000" b="1" dirty="0"/>
+              <a:t>	</a:t>
+            </a:r>
+            <a:r>
+              <a:rPr sz="2000" b="1" dirty="0"/>
               <a:t>1ST23CY002 – Abhishek P</a:t>
             </a:r>
           </a:p>
           <a:p>
-            <a:r>
+            <a:pPr marL="0" indent="0">
+              <a:buNone/>
+            </a:pPr>
+            <a:r>
+              <a:rPr lang="en-US" sz="2000" b="1" dirty="0"/>
+              <a:t>	</a:t>
+            </a:r>
+            <a:r>
+              <a:rPr sz="2000" b="1" dirty="0"/>
               <a:t>1ST23CY020 – Himanshu K R</a:t>
             </a:r>
           </a:p>
         </p:txBody>
       </p:sp>
+      <p:pic>
+        <p:nvPicPr>
+          <p:cNvPr id="5" name="Picture 4">
+            <a:extLst>
+              <a:ext uri="{FF2B5EF4-FFF2-40B4-BE49-F238E27FC236}">
+                <a16:creationId xmlns:a16="http://schemas.microsoft.com/office/drawing/2014/main" id="{4344E984-E3BB-D196-C4FA-3C9EA07ABF8E}"/>
+              </a:ext>
+            </a:extLst>
+          </p:cNvPr>
+          <p:cNvPicPr>
+            <a:picLocks noChangeAspect="1"/>
+          </p:cNvPicPr>
+          <p:nvPr/>
+        </p:nvPicPr>
+        <p:blipFill>
+          <a:blip r:embed="rId2"/>
+          <a:stretch>
+            <a:fillRect/>
+          </a:stretch>
+        </p:blipFill>
+        <p:spPr>
+          <a:xfrm>
+            <a:off x="2367534" y="473964"/>
+            <a:ext cx="4610100" cy="990600"/>
+          </a:xfrm>
+          <a:prstGeom prst="rect">
+            <a:avLst/>
+          </a:prstGeom>
+        </p:spPr>
+      </p:pic>
     </p:spTree>
   </p:cSld>
   <p:clrMapOvr>
@@ -13617,12 +13683,18 @@
             <p:ph type="title"/>
           </p:nvPr>
         </p:nvSpPr>
-        <p:spPr/>
+        <p:spPr>
+          <a:xfrm>
+            <a:off x="864382" y="725930"/>
+            <a:ext cx="6343672" cy="709865"/>
+          </a:xfrm>
+        </p:spPr>
         <p:txBody>
           <a:bodyPr/>
           <a:lstStyle/>
           <a:p>
             <a:r>
+              <a:rPr dirty="0"/>
               <a:t>BEHAVIORAL FIM (AI-Powered File Integrity Monitoring)</a:t>
             </a:r>
           </a:p>
@@ -13638,75 +13710,165 @@
             <p:ph idx="1"/>
           </p:nvPr>
         </p:nvSpPr>
-        <p:spPr/>
+        <p:spPr>
+          <a:xfrm>
+            <a:off x="862794" y="2253488"/>
+            <a:ext cx="6345260" cy="3530600"/>
+          </a:xfrm>
+        </p:spPr>
         <p:txBody>
           <a:bodyPr>
-            <a:normAutofit fontScale="55000" lnSpcReduction="20000"/>
+            <a:noAutofit/>
           </a:bodyPr>
           <a:lstStyle/>
           <a:p>
             <a:r>
-              <a:t>Proposed Solution:</a:t>
-            </a:r>
-          </a:p>
-          <a:p>
-            <a:r>
+              <a:rPr sz="1400" b="1" dirty="0"/>
+              <a:t>Proposed Solution</a:t>
+            </a:r>
+            <a:r>
+              <a:rPr lang="en-IN" sz="1400" b="1" dirty="0"/>
+              <a:t>:</a:t>
+            </a:r>
+          </a:p>
+          <a:p>
+            <a:pPr marL="0" indent="0">
+              <a:buNone/>
+            </a:pPr>
+            <a:r>
+              <a:rPr lang="en-US" sz="1300" b="1" dirty="0"/>
+              <a:t>	</a:t>
+            </a:r>
+            <a:r>
+              <a:rPr sz="1300" b="1" dirty="0"/>
               <a:t>• AI-powered context-aware File Integrity Monitoring system</a:t>
             </a:r>
           </a:p>
           <a:p>
-            <a:r>
+            <a:pPr marL="0" indent="0">
+              <a:buNone/>
+            </a:pPr>
+            <a:r>
+              <a:rPr lang="en-US" sz="1300" b="1" dirty="0"/>
+              <a:t>      	</a:t>
+            </a:r>
+            <a:r>
+              <a:rPr sz="1300" b="1" dirty="0"/>
               <a:t>• Learns normal user and role-based behavior</a:t>
             </a:r>
           </a:p>
           <a:p>
-            <a:r>
+            <a:pPr marL="0" indent="0">
+              <a:buNone/>
+            </a:pPr>
+            <a:r>
+              <a:rPr lang="en-US" sz="1300" b="1" dirty="0"/>
+              <a:t>      	</a:t>
+            </a:r>
+            <a:r>
+              <a:rPr sz="1300" b="1" dirty="0"/>
               <a:t>• Detects real anomalies instead of rule-based alerts</a:t>
             </a:r>
           </a:p>
           <a:p>
-            <a:endParaRPr/>
-          </a:p>
-          <a:p>
-            <a:r>
+            <a:r>
+              <a:rPr sz="1400" b="1" dirty="0"/>
               <a:t>How it Addresses the Problem:</a:t>
             </a:r>
           </a:p>
           <a:p>
-            <a:r>
+            <a:pPr marL="0" indent="0">
+              <a:buNone/>
+            </a:pPr>
+            <a:r>
+              <a:rPr lang="en-US" sz="1300" b="1" dirty="0"/>
+              <a:t>	</a:t>
+            </a:r>
+            <a:r>
+              <a:rPr sz="1300" b="1" dirty="0"/>
               <a:t>• Reduces alert fatigue</a:t>
             </a:r>
           </a:p>
           <a:p>
-            <a:r>
-              <a:t>• Differentiates benign vs malicious changes</a:t>
-            </a:r>
-          </a:p>
-          <a:p>
-            <a:r>
+            <a:pPr marL="0" indent="0">
+              <a:buNone/>
+            </a:pPr>
+            <a:r>
+              <a:rPr lang="en-US" sz="1300" b="1" dirty="0"/>
+              <a:t>	</a:t>
+            </a:r>
+            <a:r>
+              <a:rPr sz="1300" b="1"/>
+              <a:t>• Differentiates</a:t>
+            </a:r>
+            <a:r>
+              <a:rPr lang="en-US" sz="1300" b="1"/>
+              <a:t> good</a:t>
+            </a:r>
+            <a:r>
+              <a:rPr sz="1300" b="1"/>
+              <a:t> </a:t>
+            </a:r>
+            <a:r>
+              <a:rPr sz="1300" b="1" dirty="0"/>
+              <a:t>vs malicious changes</a:t>
+            </a:r>
+          </a:p>
+          <a:p>
+            <a:pPr marL="0" indent="0">
+              <a:buNone/>
+            </a:pPr>
+            <a:r>
+              <a:rPr lang="en-US" sz="1300" b="1" dirty="0"/>
+              <a:t>	</a:t>
+            </a:r>
+            <a:r>
+              <a:rPr sz="1300" b="1" dirty="0"/>
               <a:t>• Detects insider threats effectively</a:t>
             </a:r>
           </a:p>
           <a:p>
-            <a:endParaRPr/>
-          </a:p>
-          <a:p>
-            <a:r>
+            <a:r>
+              <a:rPr sz="1400" b="1" dirty="0"/>
               <a:t>Innovation &amp; Uniqueness:</a:t>
             </a:r>
           </a:p>
           <a:p>
-            <a:r>
+            <a:pPr marL="0" indent="0">
+              <a:buNone/>
+            </a:pPr>
+            <a:r>
+              <a:rPr lang="en-US" sz="1300" b="1" dirty="0"/>
+              <a:t>	</a:t>
+            </a:r>
+            <a:r>
+              <a:rPr sz="1300" b="1" dirty="0"/>
               <a:t>• Behavioral-based detection</a:t>
             </a:r>
           </a:p>
           <a:p>
-            <a:r>
+            <a:pPr marL="0" indent="0">
+              <a:buNone/>
+            </a:pPr>
+            <a:r>
+              <a:rPr lang="en-US" sz="1300" b="1" dirty="0"/>
+              <a:t>	</a:t>
+            </a:r>
+            <a:r>
+              <a:rPr sz="1300" b="1" dirty="0"/>
               <a:t>• ML anomaly detection (Isolation Forest)</a:t>
             </a:r>
           </a:p>
           <a:p>
-            <a:r>
+            <a:pPr marL="0" indent="0">
+              <a:buNone/>
+            </a:pPr>
+            <a:r>
+              <a:rPr lang="en-US" sz="1300" b="1" dirty="0"/>
+              <a:t>	</a:t>
+            </a:r>
+            <a:r>
+              <a:rPr sz="1300" b="1" dirty="0"/>
               <a:t>• Dynamic risk scoring</a:t>
             </a:r>
           </a:p>
@@ -13836,7 +13998,12 @@
             <p:ph type="title"/>
           </p:nvPr>
         </p:nvSpPr>
-        <p:spPr/>
+        <p:spPr>
+          <a:xfrm>
+            <a:off x="865970" y="841754"/>
+            <a:ext cx="6343672" cy="709865"/>
+          </a:xfrm>
+        </p:spPr>
         <p:txBody>
           <a:bodyPr/>
           <a:lstStyle/>
@@ -13857,77 +14024,192 @@
             <p:ph idx="1"/>
           </p:nvPr>
         </p:nvSpPr>
-        <p:spPr/>
+        <p:spPr>
+          <a:xfrm>
+            <a:off x="864382" y="2233168"/>
+            <a:ext cx="6345260" cy="3530600"/>
+          </a:xfrm>
+        </p:spPr>
         <p:txBody>
           <a:bodyPr>
-            <a:normAutofit fontScale="55000" lnSpcReduction="20000"/>
+            <a:noAutofit/>
           </a:bodyPr>
           <a:lstStyle/>
           <a:p>
             <a:r>
+              <a:rPr sz="1400" b="1" dirty="0"/>
               <a:t>Technologies Used:</a:t>
             </a:r>
           </a:p>
           <a:p>
-            <a:r>
-              <a:t>• Backend: Python, FastAPI</a:t>
-            </a:r>
-          </a:p>
-          <a:p>
-            <a:r>
-              <a:t>• ML: scikit-learn, numpy, pandas</a:t>
-            </a:r>
-          </a:p>
-          <a:p>
-            <a:r>
+            <a:pPr marL="0" indent="0">
+              <a:buNone/>
+            </a:pPr>
+            <a:r>
+              <a:rPr lang="en-US" sz="1200" b="1" dirty="0"/>
+              <a:t>	</a:t>
+            </a:r>
+            <a:r>
+              <a:rPr sz="1200" b="1" dirty="0"/>
+              <a:t>• Backend: Python, </a:t>
+            </a:r>
+            <a:r>
+              <a:rPr sz="1200" b="1" dirty="0" err="1"/>
+              <a:t>FastAPI</a:t>
+            </a:r>
+            <a:endParaRPr sz="1200" b="1" dirty="0"/>
+          </a:p>
+          <a:p>
+            <a:pPr marL="0" indent="0">
+              <a:buNone/>
+            </a:pPr>
+            <a:r>
+              <a:rPr lang="en-US" sz="1200" b="1" dirty="0"/>
+              <a:t>	</a:t>
+            </a:r>
+            <a:r>
+              <a:rPr sz="1200" b="1" dirty="0"/>
+              <a:t>• ML: scikit-learn, </a:t>
+            </a:r>
+            <a:r>
+              <a:rPr sz="1200" b="1" dirty="0" err="1"/>
+              <a:t>numpy</a:t>
+            </a:r>
+            <a:r>
+              <a:rPr sz="1200" b="1" dirty="0"/>
+              <a:t>, pandas</a:t>
+            </a:r>
+          </a:p>
+          <a:p>
+            <a:pPr marL="0" indent="0">
+              <a:buNone/>
+            </a:pPr>
+            <a:r>
+              <a:rPr lang="en-US" sz="1200" b="1" dirty="0"/>
+              <a:t>	</a:t>
+            </a:r>
+            <a:r>
+              <a:rPr sz="1200" b="1" dirty="0"/>
               <a:t>• Frontend: HTML, CSS, JavaScript (Jinja2)</a:t>
             </a:r>
           </a:p>
           <a:p>
-            <a:r>
-              <a:t>• Real-time: WebSockets</a:t>
-            </a:r>
-          </a:p>
-          <a:p>
-            <a:r>
-              <a:t>• Monitoring: watchdog, psutil</a:t>
-            </a:r>
-          </a:p>
-          <a:p>
-            <a:endParaRPr/>
-          </a:p>
-          <a:p>
-            <a:r>
+            <a:pPr marL="0" indent="0">
+              <a:buNone/>
+            </a:pPr>
+            <a:r>
+              <a:rPr lang="en-US" sz="1200" b="1" dirty="0"/>
+              <a:t>	</a:t>
+            </a:r>
+            <a:r>
+              <a:rPr sz="1200" b="1" dirty="0"/>
+              <a:t>• Real-time: </a:t>
+            </a:r>
+            <a:r>
+              <a:rPr sz="1200" b="1" dirty="0" err="1"/>
+              <a:t>WebSockets</a:t>
+            </a:r>
+            <a:endParaRPr sz="1200" b="1" dirty="0"/>
+          </a:p>
+          <a:p>
+            <a:pPr marL="0" indent="0">
+              <a:buNone/>
+            </a:pPr>
+            <a:r>
+              <a:rPr lang="en-US" sz="1200" b="1" dirty="0"/>
+              <a:t>	</a:t>
+            </a:r>
+            <a:r>
+              <a:rPr sz="1200" b="1" dirty="0"/>
+              <a:t>• Monitoring: watchdog, </a:t>
+            </a:r>
+            <a:r>
+              <a:rPr sz="1200" b="1" dirty="0" err="1"/>
+              <a:t>psutil</a:t>
+            </a:r>
+            <a:endParaRPr sz="1200" b="1" dirty="0"/>
+          </a:p>
+          <a:p>
+            <a:r>
+              <a:rPr sz="1400" b="1" dirty="0"/>
               <a:t>Implementation Process:</a:t>
             </a:r>
           </a:p>
           <a:p>
-            <a:r>
+            <a:pPr marL="0" indent="0">
+              <a:buNone/>
+            </a:pPr>
+            <a:r>
+              <a:rPr lang="en-US" sz="1200" b="1" dirty="0"/>
+              <a:t>	</a:t>
+            </a:r>
+            <a:r>
+              <a:rPr sz="1200" b="1" dirty="0"/>
               <a:t>1. Monitor file events</a:t>
             </a:r>
           </a:p>
           <a:p>
-            <a:r>
+            <a:pPr marL="0" indent="0">
+              <a:buNone/>
+            </a:pPr>
+            <a:r>
+              <a:rPr lang="en-US" sz="1200" b="1" dirty="0"/>
+              <a:t>	</a:t>
+            </a:r>
+            <a:r>
+              <a:rPr sz="1200" b="1" dirty="0"/>
               <a:t>2. Collect user activity data</a:t>
             </a:r>
           </a:p>
           <a:p>
-            <a:r>
+            <a:pPr marL="0" indent="0">
+              <a:buNone/>
+            </a:pPr>
+            <a:r>
+              <a:rPr lang="en-US" sz="1200" b="1" dirty="0"/>
+              <a:t>	</a:t>
+            </a:r>
+            <a:r>
+              <a:rPr sz="1200" b="1" dirty="0"/>
               <a:t>3. Apply K-Means clustering</a:t>
             </a:r>
           </a:p>
           <a:p>
-            <a:r>
+            <a:pPr marL="0" indent="0">
+              <a:buNone/>
+            </a:pPr>
+            <a:r>
+              <a:rPr lang="en-US" sz="1200" b="1" dirty="0"/>
+              <a:t>	</a:t>
+            </a:r>
+            <a:r>
+              <a:rPr sz="1200" b="1" dirty="0"/>
               <a:t>4. Use Isolation Forest for anomaly detection</a:t>
             </a:r>
           </a:p>
           <a:p>
-            <a:r>
+            <a:pPr marL="0" indent="0">
+              <a:buNone/>
+            </a:pPr>
+            <a:r>
+              <a:rPr lang="en-US" sz="1200" b="1" dirty="0"/>
+              <a:t>	</a:t>
+            </a:r>
+            <a:r>
+              <a:rPr sz="1200" b="1" dirty="0"/>
               <a:t>5. Generate dynamic risk score</a:t>
             </a:r>
           </a:p>
           <a:p>
-            <a:r>
+            <a:pPr marL="0" indent="0">
+              <a:buNone/>
+            </a:pPr>
+            <a:r>
+              <a:rPr lang="en-US" sz="1200" b="1" dirty="0"/>
+              <a:t>	</a:t>
+            </a:r>
+            <a:r>
+              <a:rPr sz="1200" b="1" dirty="0"/>
               <a:t>6. Display alerts on dashboard</a:t>
             </a:r>
           </a:p>
@@ -13968,12 +14250,18 @@
             <p:ph type="title"/>
           </p:nvPr>
         </p:nvSpPr>
-        <p:spPr/>
+        <p:spPr>
+          <a:xfrm>
+            <a:off x="865970" y="766731"/>
+            <a:ext cx="6343672" cy="709865"/>
+          </a:xfrm>
+        </p:spPr>
         <p:txBody>
           <a:bodyPr/>
           <a:lstStyle/>
           <a:p>
             <a:r>
+              <a:rPr dirty="0"/>
               <a:t>FEASIBILITY AND VIABILITY</a:t>
             </a:r>
           </a:p>
@@ -13989,75 +14277,149 @@
             <p:ph idx="1"/>
           </p:nvPr>
         </p:nvSpPr>
-        <p:spPr/>
+        <p:spPr>
+          <a:xfrm>
+            <a:off x="864382" y="2205736"/>
+            <a:ext cx="6345260" cy="3530600"/>
+          </a:xfrm>
+        </p:spPr>
         <p:txBody>
           <a:bodyPr>
-            <a:normAutofit fontScale="55000" lnSpcReduction="20000"/>
+            <a:noAutofit/>
           </a:bodyPr>
           <a:lstStyle/>
           <a:p>
             <a:r>
+              <a:rPr sz="1400" b="1" dirty="0"/>
               <a:t>Feasibility:</a:t>
             </a:r>
           </a:p>
           <a:p>
-            <a:r>
+            <a:pPr marL="0" indent="0">
+              <a:buNone/>
+            </a:pPr>
+            <a:r>
+              <a:rPr lang="en-US" sz="1200" b="1" dirty="0"/>
+              <a:t>	</a:t>
+            </a:r>
+            <a:r>
+              <a:rPr sz="1200" b="1" dirty="0"/>
               <a:t>• Open-source ML libraries</a:t>
             </a:r>
           </a:p>
           <a:p>
-            <a:r>
+            <a:pPr marL="0" indent="0">
+              <a:buNone/>
+            </a:pPr>
+            <a:r>
+              <a:rPr lang="en-US" sz="1200" b="1" dirty="0"/>
+              <a:t>	</a:t>
+            </a:r>
+            <a:r>
+              <a:rPr sz="1200" b="1" dirty="0"/>
               <a:t>• Scalable backend architecture</a:t>
             </a:r>
           </a:p>
           <a:p>
-            <a:r>
+            <a:pPr marL="0" indent="0">
+              <a:buNone/>
+            </a:pPr>
+            <a:r>
+              <a:rPr lang="en-US" sz="1200" b="1" dirty="0"/>
+              <a:t>	</a:t>
+            </a:r>
+            <a:r>
+              <a:rPr sz="1200" b="1" dirty="0"/>
               <a:t>• Easy integration with enterprise systems</a:t>
             </a:r>
           </a:p>
           <a:p>
-            <a:endParaRPr/>
-          </a:p>
-          <a:p>
-            <a:r>
+            <a:r>
+              <a:rPr sz="1400" b="1" dirty="0"/>
               <a:t>Challenges:</a:t>
             </a:r>
           </a:p>
           <a:p>
-            <a:r>
+            <a:pPr marL="0" indent="0">
+              <a:buNone/>
+            </a:pPr>
+            <a:r>
+              <a:rPr lang="en-US" sz="1200" b="1" dirty="0"/>
+              <a:t>	</a:t>
+            </a:r>
+            <a:r>
+              <a:rPr sz="1200" b="1" dirty="0"/>
               <a:t>• Training data quality</a:t>
             </a:r>
           </a:p>
           <a:p>
-            <a:r>
+            <a:pPr marL="0" indent="0">
+              <a:buNone/>
+            </a:pPr>
+            <a:r>
+              <a:rPr lang="en-US" sz="1200" b="1" dirty="0"/>
+              <a:t>	</a:t>
+            </a:r>
+            <a:r>
+              <a:rPr sz="1200" b="1" dirty="0"/>
               <a:t>• Initial anomaly calibration</a:t>
             </a:r>
           </a:p>
           <a:p>
-            <a:r>
+            <a:pPr marL="0" indent="0">
+              <a:buNone/>
+            </a:pPr>
+            <a:r>
+              <a:rPr lang="en-US" sz="1200" b="1" dirty="0"/>
+              <a:t>	</a:t>
+            </a:r>
+            <a:r>
+              <a:rPr sz="1200" b="1" dirty="0"/>
               <a:t>• Legacy system integration</a:t>
             </a:r>
           </a:p>
           <a:p>
-            <a:endParaRPr/>
-          </a:p>
-          <a:p>
-            <a:r>
+            <a:r>
+              <a:rPr sz="1400" b="1" dirty="0"/>
               <a:t>Mitigation Strategies:</a:t>
             </a:r>
           </a:p>
           <a:p>
-            <a:r>
+            <a:pPr marL="0" indent="0">
+              <a:buNone/>
+            </a:pPr>
+            <a:r>
+              <a:rPr lang="en-US" sz="1200" b="1" dirty="0"/>
+              <a:t>	</a:t>
+            </a:r>
+            <a:r>
+              <a:rPr sz="1200" b="1" dirty="0"/>
               <a:t>• Continuous model retraining</a:t>
             </a:r>
           </a:p>
           <a:p>
-            <a:r>
+            <a:pPr marL="0" indent="0">
+              <a:buNone/>
+            </a:pPr>
+            <a:r>
+              <a:rPr lang="en-US" sz="1200" b="1" dirty="0"/>
+              <a:t>	</a:t>
+            </a:r>
+            <a:r>
+              <a:rPr sz="1200" b="1" dirty="0"/>
               <a:t>• Role-based baseline calibration</a:t>
             </a:r>
           </a:p>
           <a:p>
-            <a:r>
+            <a:pPr marL="0" indent="0">
+              <a:buNone/>
+            </a:pPr>
+            <a:r>
+              <a:rPr lang="en-US" sz="1200" b="1" dirty="0"/>
+              <a:t>	</a:t>
+            </a:r>
+            <a:r>
+              <a:rPr sz="1200" b="1" dirty="0"/>
               <a:t>• Docker/Kubernetes deployment</a:t>
             </a:r>
           </a:p>
@@ -14122,54 +14484,110 @@
         <p:spPr/>
         <p:txBody>
           <a:bodyPr>
-            <a:normAutofit fontScale="92500" lnSpcReduction="20000"/>
+            <a:normAutofit/>
           </a:bodyPr>
           <a:lstStyle/>
           <a:p>
             <a:r>
+              <a:rPr sz="1400" b="1" dirty="0"/>
               <a:t>Target Audience:</a:t>
             </a:r>
           </a:p>
           <a:p>
-            <a:r>
+            <a:pPr marL="0" indent="0">
+              <a:buNone/>
+            </a:pPr>
+            <a:r>
+              <a:rPr lang="en-US" sz="1200" b="1" dirty="0"/>
+              <a:t>	</a:t>
+            </a:r>
+            <a:r>
+              <a:rPr sz="1200" b="1" dirty="0"/>
               <a:t>• SOC Teams</a:t>
             </a:r>
           </a:p>
           <a:p>
-            <a:r>
+            <a:pPr marL="0" indent="0">
+              <a:buNone/>
+            </a:pPr>
+            <a:r>
+              <a:rPr lang="en-US" sz="1200" b="1" dirty="0"/>
+              <a:t>	</a:t>
+            </a:r>
+            <a:r>
+              <a:rPr sz="1200" b="1" dirty="0"/>
               <a:t>• Enterprises handling sensitive data</a:t>
             </a:r>
           </a:p>
           <a:p>
-            <a:r>
+            <a:pPr marL="0" indent="0">
+              <a:buNone/>
+            </a:pPr>
+            <a:r>
+              <a:rPr lang="en-US" sz="1200" b="1" dirty="0"/>
+              <a:t>	</a:t>
+            </a:r>
+            <a:r>
+              <a:rPr sz="1200" b="1" dirty="0"/>
               <a:t>• Critical infrastructure organizations</a:t>
             </a:r>
           </a:p>
           <a:p>
-            <a:endParaRPr/>
-          </a:p>
-          <a:p>
-            <a:r>
+            <a:r>
+              <a:rPr sz="1400" b="1" dirty="0"/>
               <a:t>Benefits:</a:t>
             </a:r>
-          </a:p>
-          <a:p>
-            <a:r>
+            <a:endParaRPr lang="en-US" sz="1400" b="1" dirty="0"/>
+          </a:p>
+          <a:p>
+            <a:pPr marL="0" indent="0">
+              <a:buNone/>
+            </a:pPr>
+            <a:r>
+              <a:rPr lang="en-IN" sz="1400" b="1" dirty="0"/>
+              <a:t>	</a:t>
+            </a:r>
+            <a:r>
+              <a:rPr sz="1200" b="1" dirty="0"/>
               <a:t>• Reduces false positives</a:t>
             </a:r>
           </a:p>
           <a:p>
-            <a:r>
+            <a:pPr marL="0" indent="0">
+              <a:buNone/>
+            </a:pPr>
+            <a:r>
+              <a:rPr lang="en-US" sz="1200" b="1" dirty="0"/>
+              <a:t>	</a:t>
+            </a:r>
+            <a:r>
+              <a:rPr sz="1200" b="1" dirty="0"/>
               <a:t>• Faster incident response</a:t>
             </a:r>
           </a:p>
           <a:p>
-            <a:r>
+            <a:pPr marL="0" indent="0">
+              <a:buNone/>
+            </a:pPr>
+            <a:r>
+              <a:rPr lang="en-US" sz="1200" b="1" dirty="0"/>
+              <a:t>	</a:t>
+            </a:r>
+            <a:r>
+              <a:rPr sz="1200" b="1" dirty="0"/>
               <a:t>• Improved compliance</a:t>
             </a:r>
           </a:p>
           <a:p>
-            <a:r>
+            <a:pPr marL="0" indent="0">
+              <a:buNone/>
+            </a:pPr>
+            <a:r>
+              <a:rPr lang="en-US" sz="1200" b="1" dirty="0"/>
+              <a:t>	</a:t>
+            </a:r>
+            <a:r>
+              <a:rPr sz="1200" b="1" dirty="0"/>
               <a:t>• Actionable security intelligence</a:t>
             </a:r>
           </a:p>

</xml_diff>